<commit_message>
Incorporate useful points from the alternate deck
Add an income-ETF framework slide for JEPI, a total-return reminder,
and short clarifications on yield gaps, CDS moves, maturity counts,
sector active share, selection effect, and reading fund descriptions.

Co-Authored-By: Claude Opus 5.5 <noreply@anthropic.com>
Claude-Session: https://claude.ai/code/session_016iRCNRPSyZ7faN5ZQS7vng
</commit_message>
<xml_diff>
--- a/fina4126/ETF_Performance_Evaluation_Bond_Screening_Revised.pptx
+++ b/fina4126/ETF_Performance_Evaluation_Bond_Screening_Revised.pptx
@@ -70,6 +70,7 @@
     <p:sldId id="315" r:id="rId68"/>
     <p:sldId id="316" r:id="rId69"/>
     <p:sldId id="317" r:id="rId70"/>
+    <p:sldId id="318" r:id="rId71"/>
   </p:sldIdLst>
   <p:sldSz cx="12192000" cy="6858000"/>
   <p:notesSz cx="6858000" cy="9144000"/>
@@ -6512,6 +6513,30 @@
               <a:t>Hold contractual terms constant (currency, coupon type, maturity), then ask what is left to explain the gap.</a:t>
             </a:r>
           </a:p>
+          <a:p>
+            <a:pPr marL="400050" indent="-400050">
+              <a:buFont typeface="Arial"/>
+              <a:buChar char="•"/>
+              <a:lnSpc>
+                <a:spcPct val="110000"/>
+              </a:lnSpc>
+              <a:spcBef>
+                <a:spcPts val="0"/>
+              </a:spcBef>
+              <a:spcAft>
+                <a:spcPts val="1200"/>
+              </a:spcAft>
+            </a:pPr>
+            <a:r>
+              <a:rPr sz="2800" b="0">
+                <a:solidFill>
+                  <a:srgbClr val="000000"/>
+                </a:solidFill>
+                <a:latin typeface="Arial"/>
+              </a:rPr>
+              <a:t>A yield gap is market compensation for risk, not a standalone ranking of issuer quality.</a:t>
+            </a:r>
+          </a:p>
         </p:txBody>
       </p:sp>
     </p:spTree>
@@ -9667,7 +9692,7 @@
                 </a:solidFill>
                 <a:latin typeface="Arial"/>
               </a:rPr>
-              <a:t>Use dollar amounts (USD mm), not the number of instruments.</a:t>
+              <a:t>Use dollar amounts (USD mm), not the number of instruments, unless asked for a count.</a:t>
             </a:r>
           </a:p>
           <a:p>
@@ -10753,7 +10778,7 @@
                 </a:solidFill>
                 <a:latin typeface="Arial"/>
               </a:rPr>
-              <a:t>Drivers: earnings, leverage, company news, and sector-wide stress.</a:t>
+              <a:t>A spread move is a signal to investigate in context, not the full credit story.</a:t>
             </a:r>
           </a:p>
           <a:p>
@@ -13285,7 +13310,7 @@
                 </a:solidFill>
                 <a:latin typeface="Arial"/>
               </a:rPr>
-              <a:t>Switch sectors from GICS to FactSet:</a:t>
+              <a:t>Switch sectors to FactSet so names match the dropdowns:</a:t>
             </a:r>
           </a:p>
           <a:p>
@@ -13684,7 +13709,7 @@
                 </a:solidFill>
                 <a:latin typeface="Arial"/>
               </a:rPr>
-              <a:t>Read the description on the Fund Overview tab and match its language to these terms.</a:t>
+              <a:t>Read the Fund Overview and Fund Insight text, not just the fund name, and match its language to these terms.</a:t>
             </a:r>
           </a:p>
         </p:txBody>
@@ -16775,7 +16800,7 @@
                 </a:solidFill>
                 <a:latin typeface="Arial"/>
               </a:rPr>
-              <a:t>The largest contributor is the sector with the highest contribution figure in the table.</a:t>
+              <a:t>Use the table’s contribution figure, not the headline sector weights.</a:t>
             </a:r>
           </a:p>
           <a:p>
@@ -17612,6 +17637,30 @@
               <a:t>A sector can show strong selection even while its allocation effect is negative.</a:t>
             </a:r>
           </a:p>
+          <a:p>
+            <a:pPr marL="400050" indent="-400050">
+              <a:buFont typeface="Arial"/>
+              <a:buChar char="•"/>
+              <a:lnSpc>
+                <a:spcPct val="110000"/>
+              </a:lnSpc>
+              <a:spcBef>
+                <a:spcPts val="0"/>
+              </a:spcBef>
+              <a:spcAft>
+                <a:spcPts val="1200"/>
+              </a:spcAft>
+            </a:pPr>
+            <a:r>
+              <a:rPr sz="2800" b="0">
+                <a:solidFill>
+                  <a:srgbClr val="000000"/>
+                </a:solidFill>
+                <a:latin typeface="Arial"/>
+              </a:rPr>
+              <a:t>Selection can be positive even when the fund lags the benchmark overall.</a:t>
+            </a:r>
+          </a:p>
         </p:txBody>
       </p:sp>
     </p:spTree>
@@ -18602,7 +18651,7 @@
                 </a:solidFill>
                 <a:latin typeface="Arial"/>
               </a:rPr>
-              <a:t>Concept: Options-Based Income</a:t>
+              <a:t>Framework: Evaluating an Income ETF</a:t>
             </a:r>
           </a:p>
         </p:txBody>
@@ -18687,103 +18736,127 @@
               </a:spcAft>
             </a:pPr>
             <a:r>
+              <a:rPr sz="2800" b="0">
+                <a:solidFill>
+                  <a:srgbClr val="000000"/>
+                </a:solidFill>
+                <a:latin typeface="Arial"/>
+              </a:rPr>
+              <a:t>Start with the stated objective: income, volatility, and equity exposure.</a:t>
+            </a:r>
+          </a:p>
+          <a:p>
+            <a:pPr marL="400050" indent="-400050">
+              <a:buFont typeface="Arial"/>
+              <a:buChar char="•"/>
+              <a:lnSpc>
+                <a:spcPct val="110000"/>
+              </a:lnSpc>
+              <a:spcBef>
+                <a:spcPts val="0"/>
+              </a:spcBef>
+              <a:spcAft>
+                <a:spcPts val="1200"/>
+              </a:spcAft>
+            </a:pPr>
+            <a:r>
+              <a:rPr sz="2800" b="0">
+                <a:solidFill>
+                  <a:srgbClr val="000000"/>
+                </a:solidFill>
+                <a:latin typeface="Arial"/>
+              </a:rPr>
+              <a:t>Compare the fund with its assigned benchmark: SPY.</a:t>
+            </a:r>
+          </a:p>
+          <a:p>
+            <a:pPr marL="400050" indent="-400050">
+              <a:buFont typeface="Arial"/>
+              <a:buChar char="•"/>
+              <a:lnSpc>
+                <a:spcPct val="110000"/>
+              </a:lnSpc>
+              <a:spcBef>
+                <a:spcPts val="0"/>
+              </a:spcBef>
+              <a:spcAft>
+                <a:spcPts val="1200"/>
+              </a:spcAft>
+            </a:pPr>
+            <a:r>
+              <a:rPr sz="2800" b="0">
+                <a:solidFill>
+                  <a:srgbClr val="000000"/>
+                </a:solidFill>
+                <a:latin typeface="Arial"/>
+              </a:rPr>
+              <a:t>Separate strategy design from realized performance.</a:t>
+            </a:r>
+          </a:p>
+          <a:p>
+            <a:pPr marL="400050" indent="-400050">
+              <a:buFont typeface="Arial"/>
+              <a:buChar char="•"/>
+              <a:lnSpc>
+                <a:spcPct val="110000"/>
+              </a:lnSpc>
+              <a:spcBef>
+                <a:spcPts val="0"/>
+              </a:spcBef>
+              <a:spcAft>
+                <a:spcPts val="1200"/>
+              </a:spcAft>
+            </a:pPr>
+            <a:r>
+              <a:rPr sz="2800" b="0">
+                <a:solidFill>
+                  <a:srgbClr val="000000"/>
+                </a:solidFill>
+                <a:latin typeface="Arial"/>
+              </a:rPr>
+              <a:t>Use cumulative </a:t>
+            </a:r>
+            <a:r>
               <a:rPr sz="2800" b="1">
                 <a:solidFill>
                   <a:srgbClr val="000000"/>
                 </a:solidFill>
                 <a:latin typeface="Arial"/>
               </a:rPr>
-              <a:t>Covered call:</a:t>
-            </a:r>
-            <a:r>
-              <a:rPr sz="2800" b="0">
-                <a:solidFill>
-                  <a:srgbClr val="000000"/>
-                </a:solidFill>
-                <a:latin typeface="Arial"/>
-              </a:rPr>
-              <a:t> own a stock and sell a call option on it; collect premium now, give up gains above the strike.</a:t>
-            </a:r>
-          </a:p>
-          <a:p>
-            <a:pPr marL="400050" indent="-400050">
-              <a:buFont typeface="Arial"/>
-              <a:buChar char="•"/>
-              <a:lnSpc>
-                <a:spcPct val="110000"/>
-              </a:lnSpc>
-              <a:spcBef>
-                <a:spcPts val="0"/>
-              </a:spcBef>
-              <a:spcAft>
-                <a:spcPts val="1200"/>
-              </a:spcAft>
-            </a:pPr>
-            <a:r>
-              <a:rPr sz="2800" b="1">
-                <a:solidFill>
-                  <a:srgbClr val="000000"/>
-                </a:solidFill>
-                <a:latin typeface="Arial"/>
-              </a:rPr>
-              <a:t>Equity-linked note (ELN):</a:t>
-            </a:r>
-            <a:r>
-              <a:rPr sz="2800" b="0">
-                <a:solidFill>
-                  <a:srgbClr val="000000"/>
-                </a:solidFill>
-                <a:latin typeface="Arial"/>
-              </a:rPr>
-              <a:t> a bank-issued note whose payoff is tied to an equity index; it can package an option-selling strategy in one security.</a:t>
-            </a:r>
-          </a:p>
-          <a:p>
-            <a:pPr marL="400050" indent="-400050">
-              <a:buFont typeface="Arial"/>
-              <a:buChar char="•"/>
-              <a:lnSpc>
-                <a:spcPct val="110000"/>
-              </a:lnSpc>
-              <a:spcBef>
-                <a:spcPts val="0"/>
-              </a:spcBef>
-              <a:spcAft>
-                <a:spcPts val="1200"/>
-              </a:spcAft>
-            </a:pPr>
-            <a:r>
-              <a:rPr sz="2800" b="0">
-                <a:solidFill>
-                  <a:srgbClr val="000000"/>
-                </a:solidFill>
-                <a:latin typeface="Arial"/>
-              </a:rPr>
-              <a:t>Typical result: higher current income, lower volatility, less upside in strong rallies.</a:t>
-            </a:r>
-          </a:p>
-          <a:p>
-            <a:pPr marL="400050" indent="-400050">
-              <a:buFont typeface="Arial"/>
-              <a:buChar char="•"/>
-              <a:lnSpc>
-                <a:spcPct val="110000"/>
-              </a:lnSpc>
-              <a:spcBef>
-                <a:spcPts val="0"/>
-              </a:spcBef>
-              <a:spcAft>
-                <a:spcPts val="1200"/>
-              </a:spcAft>
-            </a:pPr>
-            <a:r>
-              <a:rPr sz="2800" b="0">
-                <a:solidFill>
-                  <a:srgbClr val="000000"/>
-                </a:solidFill>
-                <a:latin typeface="Arial"/>
-              </a:rPr>
-              <a:t>Judge an income strategy on return, income, and risk together.</a:t>
+              <a:t>total</a:t>
+            </a:r>
+            <a:r>
+              <a:rPr sz="2800" b="0">
+                <a:solidFill>
+                  <a:srgbClr val="000000"/>
+                </a:solidFill>
+                <a:latin typeface="Arial"/>
+              </a:rPr>
+              <a:t> return: income funds pay out much of their return as distributions.</a:t>
+            </a:r>
+          </a:p>
+          <a:p>
+            <a:pPr marL="400050" indent="-400050">
+              <a:buFont typeface="Arial"/>
+              <a:buChar char="•"/>
+              <a:lnSpc>
+                <a:spcPct val="110000"/>
+              </a:lnSpc>
+              <a:spcBef>
+                <a:spcPts val="0"/>
+              </a:spcBef>
+              <a:spcAft>
+                <a:spcPts val="1200"/>
+              </a:spcAft>
+            </a:pPr>
+            <a:r>
+              <a:rPr sz="2800" b="0">
+                <a:solidFill>
+                  <a:srgbClr val="000000"/>
+                </a:solidFill>
+                <a:latin typeface="Arial"/>
+              </a:rPr>
+              <a:t>Same toolkit as ARKK: exposures, active share, attribution.</a:t>
             </a:r>
           </a:p>
         </p:txBody>
@@ -18854,7 +18927,7 @@
                 </a:solidFill>
                 <a:latin typeface="Arial"/>
               </a:rPr>
-              <a:t>JEPI Q1–Q3: Reading the Fund Insight</a:t>
+              <a:t>Concept: Options-Based Income</a:t>
             </a:r>
           </a:p>
         </p:txBody>
@@ -18939,85 +19012,103 @@
               </a:spcAft>
             </a:pPr>
             <a:r>
-              <a:rPr sz="2800" b="0">
-                <a:solidFill>
-                  <a:srgbClr val="000000"/>
-                </a:solidFill>
-                <a:latin typeface="Arial"/>
-              </a:rPr>
-              <a:t>Is the fund active or passive? What universe does it select from?</a:t>
-            </a:r>
-          </a:p>
-          <a:p>
-            <a:pPr marL="400050" indent="-400050">
-              <a:buFont typeface="Arial"/>
-              <a:buChar char="•"/>
-              <a:lnSpc>
-                <a:spcPct val="110000"/>
-              </a:lnSpc>
-              <a:spcBef>
-                <a:spcPts val="0"/>
-              </a:spcBef>
-              <a:spcAft>
-                <a:spcPts val="1200"/>
-              </a:spcAft>
-            </a:pPr>
-            <a:r>
-              <a:rPr sz="2800" b="0">
-                <a:solidFill>
-                  <a:srgbClr val="000000"/>
-                </a:solidFill>
-                <a:latin typeface="Arial"/>
-              </a:rPr>
-              <a:t>What does it hold besides stocks, and what is that for?</a:t>
-            </a:r>
-          </a:p>
-          <a:p>
-            <a:pPr marL="400050" indent="-400050">
-              <a:buFont typeface="Arial"/>
-              <a:buChar char="•"/>
-              <a:lnSpc>
-                <a:spcPct val="110000"/>
-              </a:lnSpc>
-              <a:spcBef>
-                <a:spcPts val="0"/>
-              </a:spcBef>
-              <a:spcAft>
-                <a:spcPts val="1200"/>
-              </a:spcAft>
-            </a:pPr>
-            <a:r>
-              <a:rPr sz="2800" b="0">
-                <a:solidFill>
-                  <a:srgbClr val="000000"/>
-                </a:solidFill>
-                <a:latin typeface="Arial"/>
-              </a:rPr>
-              <a:t>How does ESG enter the process: exclusion, primary criterion, or one input among others?</a:t>
-            </a:r>
-          </a:p>
-          <a:p>
-            <a:pPr marL="400050" indent="-400050">
-              <a:buFont typeface="Arial"/>
-              <a:buChar char="•"/>
-              <a:lnSpc>
-                <a:spcPct val="110000"/>
-              </a:lnSpc>
-              <a:spcBef>
-                <a:spcPts val="0"/>
-              </a:spcBef>
-              <a:spcAft>
-                <a:spcPts val="1200"/>
-              </a:spcAft>
-            </a:pPr>
-            <a:r>
-              <a:rPr sz="2800" b="0">
-                <a:solidFill>
-                  <a:srgbClr val="000000"/>
-                </a:solidFill>
-                <a:latin typeface="Arial"/>
-              </a:rPr>
-              <a:t>Compare JEPI’s expense ratio with SPY’s using the actual FactSet figures.</a:t>
+              <a:rPr sz="2800" b="1">
+                <a:solidFill>
+                  <a:srgbClr val="000000"/>
+                </a:solidFill>
+                <a:latin typeface="Arial"/>
+              </a:rPr>
+              <a:t>Covered call:</a:t>
+            </a:r>
+            <a:r>
+              <a:rPr sz="2800" b="0">
+                <a:solidFill>
+                  <a:srgbClr val="000000"/>
+                </a:solidFill>
+                <a:latin typeface="Arial"/>
+              </a:rPr>
+              <a:t> own a stock and sell a call option on it; collect premium now, give up gains above the strike.</a:t>
+            </a:r>
+          </a:p>
+          <a:p>
+            <a:pPr marL="400050" indent="-400050">
+              <a:buFont typeface="Arial"/>
+              <a:buChar char="•"/>
+              <a:lnSpc>
+                <a:spcPct val="110000"/>
+              </a:lnSpc>
+              <a:spcBef>
+                <a:spcPts val="0"/>
+              </a:spcBef>
+              <a:spcAft>
+                <a:spcPts val="1200"/>
+              </a:spcAft>
+            </a:pPr>
+            <a:r>
+              <a:rPr sz="2800" b="1">
+                <a:solidFill>
+                  <a:srgbClr val="000000"/>
+                </a:solidFill>
+                <a:latin typeface="Arial"/>
+              </a:rPr>
+              <a:t>Equity-linked note (ELN):</a:t>
+            </a:r>
+            <a:r>
+              <a:rPr sz="2800" b="0">
+                <a:solidFill>
+                  <a:srgbClr val="000000"/>
+                </a:solidFill>
+                <a:latin typeface="Arial"/>
+              </a:rPr>
+              <a:t> a bank-issued note whose payoff is tied to an equity index; it can package an option-selling strategy in one security.</a:t>
+            </a:r>
+          </a:p>
+          <a:p>
+            <a:pPr marL="400050" indent="-400050">
+              <a:buFont typeface="Arial"/>
+              <a:buChar char="•"/>
+              <a:lnSpc>
+                <a:spcPct val="110000"/>
+              </a:lnSpc>
+              <a:spcBef>
+                <a:spcPts val="0"/>
+              </a:spcBef>
+              <a:spcAft>
+                <a:spcPts val="1200"/>
+              </a:spcAft>
+            </a:pPr>
+            <a:r>
+              <a:rPr sz="2800" b="0">
+                <a:solidFill>
+                  <a:srgbClr val="000000"/>
+                </a:solidFill>
+                <a:latin typeface="Arial"/>
+              </a:rPr>
+              <a:t>Typical result: higher current income, lower volatility, less upside in strong rallies.</a:t>
+            </a:r>
+          </a:p>
+          <a:p>
+            <a:pPr marL="400050" indent="-400050">
+              <a:buFont typeface="Arial"/>
+              <a:buChar char="•"/>
+              <a:lnSpc>
+                <a:spcPct val="110000"/>
+              </a:lnSpc>
+              <a:spcBef>
+                <a:spcPts val="0"/>
+              </a:spcBef>
+              <a:spcAft>
+                <a:spcPts val="1200"/>
+              </a:spcAft>
+            </a:pPr>
+            <a:r>
+              <a:rPr sz="2800" b="0">
+                <a:solidFill>
+                  <a:srgbClr val="000000"/>
+                </a:solidFill>
+                <a:latin typeface="Arial"/>
+              </a:rPr>
+              <a:t>Judge an income strategy on return, income, and risk together.</a:t>
             </a:r>
           </a:p>
         </p:txBody>
@@ -19031,6 +19122,264 @@
 </file>
 
 <file path=ppt/slides/slide62.xml><?xml version="1.0" encoding="utf-8"?>
+<p:sld xmlns:a="http://schemas.openxmlformats.org/drawingml/2006/main" xmlns:p="http://schemas.openxmlformats.org/presentationml/2006/main" xmlns:r="http://schemas.openxmlformats.org/officeDocument/2006/relationships">
+  <p:cSld>
+    <p:bg>
+      <p:bgPr>
+        <a:solidFill>
+          <a:srgbClr val="FFFFFF"/>
+        </a:solidFill>
+        <a:effectLst/>
+      </p:bgPr>
+    </p:bg>
+    <p:spTree>
+      <p:nvGrpSpPr>
+        <p:cNvPr id="1" name=""/>
+        <p:cNvGrpSpPr/>
+        <p:nvPr/>
+      </p:nvGrpSpPr>
+      <p:grpSpPr/>
+      <p:sp>
+        <p:nvSpPr>
+          <p:cNvPr id="2" name="TextBox 1"/>
+          <p:cNvSpPr txBox="1"/>
+          <p:nvPr/>
+        </p:nvSpPr>
+        <p:spPr>
+          <a:xfrm>
+            <a:off x="640080" y="420000"/>
+            <a:ext cx="10927080" cy="700000"/>
+          </a:xfrm>
+          <a:prstGeom prst="rect">
+            <a:avLst/>
+          </a:prstGeom>
+          <a:noFill/>
+        </p:spPr>
+        <p:txBody>
+          <a:bodyPr wrap="square" lIns="0" rIns="0" tIns="0" bIns="0" anchor="b">
+            <a:spAutoFit/>
+          </a:bodyPr>
+          <a:lstStyle/>
+          <a:p>
+            <a:pPr>
+              <a:lnSpc>
+                <a:spcPct val="100000"/>
+              </a:lnSpc>
+              <a:spcBef>
+                <a:spcPts val="0"/>
+              </a:spcBef>
+              <a:spcAft>
+                <a:spcPts val="0"/>
+              </a:spcAft>
+            </a:pPr>
+            <a:r>
+              <a:rPr sz="3600" b="1">
+                <a:solidFill>
+                  <a:srgbClr val="000000"/>
+                </a:solidFill>
+                <a:latin typeface="Arial"/>
+              </a:rPr>
+              <a:t>JEPI Q1–Q3: Reading the Fund Insight</a:t>
+            </a:r>
+          </a:p>
+        </p:txBody>
+      </p:sp>
+      <p:sp>
+        <p:nvSpPr>
+          <p:cNvPr id="3" name="Rectangle 2"/>
+          <p:cNvSpPr/>
+          <p:nvPr/>
+        </p:nvSpPr>
+        <p:spPr>
+          <a:xfrm>
+            <a:off x="640080" y="1234440"/>
+            <a:ext cx="10927080" cy="25603"/>
+          </a:xfrm>
+          <a:prstGeom prst="rect">
+            <a:avLst/>
+          </a:prstGeom>
+          <a:solidFill>
+            <a:srgbClr val="000000"/>
+          </a:solidFill>
+          <a:ln>
+            <a:noFill/>
+          </a:ln>
+          <a:effectLst/>
+        </p:spPr>
+        <p:style>
+          <a:lnRef idx="1">
+            <a:schemeClr val="accent1"/>
+          </a:lnRef>
+          <a:fillRef idx="3">
+            <a:schemeClr val="accent1"/>
+          </a:fillRef>
+          <a:effectRef idx="2">
+            <a:schemeClr val="accent1"/>
+          </a:effectRef>
+          <a:fontRef idx="minor">
+            <a:schemeClr val="lt1"/>
+          </a:fontRef>
+        </p:style>
+        <p:txBody>
+          <a:bodyPr rtlCol="0" anchor="ctr"/>
+          <a:lstStyle/>
+          <a:p>
+            <a:pPr algn="ctr"/>
+          </a:p>
+        </p:txBody>
+      </p:sp>
+      <p:sp>
+        <p:nvSpPr>
+          <p:cNvPr id="4" name="TextBox 3"/>
+          <p:cNvSpPr txBox="1"/>
+          <p:nvPr/>
+        </p:nvSpPr>
+        <p:spPr>
+          <a:xfrm>
+            <a:off x="640080" y="1500000"/>
+            <a:ext cx="10927080" cy="4846320"/>
+          </a:xfrm>
+          <a:prstGeom prst="rect">
+            <a:avLst/>
+          </a:prstGeom>
+          <a:noFill/>
+        </p:spPr>
+        <p:txBody>
+          <a:bodyPr wrap="square" lIns="0" rIns="0" tIns="0" bIns="0">
+            <a:spAutoFit/>
+          </a:bodyPr>
+          <a:lstStyle/>
+          <a:p>
+            <a:pPr marL="400050" indent="-400050">
+              <a:buFont typeface="Arial"/>
+              <a:buChar char="•"/>
+              <a:lnSpc>
+                <a:spcPct val="110000"/>
+              </a:lnSpc>
+              <a:spcBef>
+                <a:spcPts val="0"/>
+              </a:spcBef>
+              <a:spcAft>
+                <a:spcPts val="1200"/>
+              </a:spcAft>
+            </a:pPr>
+            <a:r>
+              <a:rPr sz="2800" b="0">
+                <a:solidFill>
+                  <a:srgbClr val="000000"/>
+                </a:solidFill>
+                <a:latin typeface="Arial"/>
+              </a:rPr>
+              <a:t>Is the fund active or passive? What universe does it select from?</a:t>
+            </a:r>
+          </a:p>
+          <a:p>
+            <a:pPr marL="400050" indent="-400050">
+              <a:buFont typeface="Arial"/>
+              <a:buChar char="•"/>
+              <a:lnSpc>
+                <a:spcPct val="110000"/>
+              </a:lnSpc>
+              <a:spcBef>
+                <a:spcPts val="0"/>
+              </a:spcBef>
+              <a:spcAft>
+                <a:spcPts val="1200"/>
+              </a:spcAft>
+            </a:pPr>
+            <a:r>
+              <a:rPr sz="2800" b="0">
+                <a:solidFill>
+                  <a:srgbClr val="000000"/>
+                </a:solidFill>
+                <a:latin typeface="Arial"/>
+              </a:rPr>
+              <a:t>What does it hold besides stocks, and what is that for?</a:t>
+            </a:r>
+          </a:p>
+          <a:p>
+            <a:pPr marL="400050" indent="-400050">
+              <a:buFont typeface="Arial"/>
+              <a:buChar char="•"/>
+              <a:lnSpc>
+                <a:spcPct val="110000"/>
+              </a:lnSpc>
+              <a:spcBef>
+                <a:spcPts val="0"/>
+              </a:spcBef>
+              <a:spcAft>
+                <a:spcPts val="1200"/>
+              </a:spcAft>
+            </a:pPr>
+            <a:r>
+              <a:rPr sz="2800" b="0">
+                <a:solidFill>
+                  <a:srgbClr val="000000"/>
+                </a:solidFill>
+                <a:latin typeface="Arial"/>
+              </a:rPr>
+              <a:t>How does ESG enter the process: exclusion, primary criterion, or one input among others?</a:t>
+            </a:r>
+          </a:p>
+          <a:p>
+            <a:pPr marL="400050" indent="-400050">
+              <a:buFont typeface="Arial"/>
+              <a:buChar char="•"/>
+              <a:lnSpc>
+                <a:spcPct val="110000"/>
+              </a:lnSpc>
+              <a:spcBef>
+                <a:spcPts val="0"/>
+              </a:spcBef>
+              <a:spcAft>
+                <a:spcPts val="1200"/>
+              </a:spcAft>
+            </a:pPr>
+            <a:r>
+              <a:rPr sz="2800" b="0">
+                <a:solidFill>
+                  <a:srgbClr val="000000"/>
+                </a:solidFill>
+                <a:latin typeface="Arial"/>
+              </a:rPr>
+              <a:t>Answer from the fund description, not from assumptions about the sponsor.</a:t>
+            </a:r>
+          </a:p>
+          <a:p>
+            <a:pPr marL="400050" indent="-400050">
+              <a:buFont typeface="Arial"/>
+              <a:buChar char="•"/>
+              <a:lnSpc>
+                <a:spcPct val="110000"/>
+              </a:lnSpc>
+              <a:spcBef>
+                <a:spcPts val="0"/>
+              </a:spcBef>
+              <a:spcAft>
+                <a:spcPts val="1200"/>
+              </a:spcAft>
+            </a:pPr>
+            <a:r>
+              <a:rPr sz="2800" b="0">
+                <a:solidFill>
+                  <a:srgbClr val="000000"/>
+                </a:solidFill>
+                <a:latin typeface="Arial"/>
+              </a:rPr>
+              <a:t>Compare JEPI’s expense ratio with SPY’s using the actual FactSet figures.</a:t>
+            </a:r>
+          </a:p>
+        </p:txBody>
+      </p:sp>
+    </p:spTree>
+  </p:cSld>
+  <p:clrMapOvr>
+    <a:masterClrMapping/>
+  </p:clrMapOvr>
+</p:sld>
+</file>
+
+<file path=ppt/slides/slide63.xml><?xml version="1.0" encoding="utf-8"?>
 <p:sld xmlns:a="http://schemas.openxmlformats.org/drawingml/2006/main" xmlns:p="http://schemas.openxmlformats.org/presentationml/2006/main" xmlns:r="http://schemas.openxmlformats.org/officeDocument/2006/relationships">
   <p:cSld>
     <p:bg>

</xml_diff>